<commit_message>
Added illustrations for the manual threshold estimation test
</commit_message>
<xml_diff>
--- a/assets/images/Experitments_Procedures_Psychophysics_ManualThresholdEstimation.pptx
+++ b/assets/images/Experitments_Procedures_Psychophysics_ManualThresholdEstimation.pptx
@@ -5,10 +5,13 @@
     <p:sldMasterId id="2147483684" r:id="rId4"/>
   </p:sldMasterIdLst>
   <p:notesMasterIdLst>
-    <p:notesMasterId r:id="rId6"/>
+    <p:notesMasterId r:id="rId9"/>
   </p:notesMasterIdLst>
   <p:sldIdLst>
     <p:sldId id="256" r:id="rId5"/>
+    <p:sldId id="258" r:id="rId6"/>
+    <p:sldId id="259" r:id="rId7"/>
+    <p:sldId id="257" r:id="rId8"/>
   </p:sldIdLst>
   <p:sldSz cx="21601113" cy="14400213"/>
   <p:notesSz cx="9144000" cy="6858000"/>
@@ -402,7 +405,7 @@
           <a:p>
             <a:fld id="{43466010-90F5-41E6-AAE8-7E580DBF8C7C}" type="datetimeFigureOut">
               <a:rPr lang="en-DK" smtClean="0"/>
-              <a:t>27/04/2026</a:t>
+              <a:t>28/04/2026</a:t>
             </a:fld>
             <a:endParaRPr lang="en-DK"/>
           </a:p>
@@ -758,6 +761,270 @@
 </p:notes>
 </file>
 
+<file path=ppt/notesSlides/notesSlide2.xml><?xml version="1.0" encoding="utf-8"?>
+<p:notes xmlns:a="http://schemas.openxmlformats.org/drawingml/2006/main" xmlns:r="http://schemas.openxmlformats.org/officeDocument/2006/relationships" xmlns:p="http://schemas.openxmlformats.org/presentationml/2006/main">
+  <p:cSld>
+    <p:spTree>
+      <p:nvGrpSpPr>
+        <p:cNvPr id="1" name=""/>
+        <p:cNvGrpSpPr/>
+        <p:nvPr/>
+      </p:nvGrpSpPr>
+      <p:grpSpPr>
+        <a:xfrm>
+          <a:off x="0" y="0"/>
+          <a:ext cx="0" cy="0"/>
+          <a:chOff x="0" y="0"/>
+          <a:chExt cx="0" cy="0"/>
+        </a:xfrm>
+      </p:grpSpPr>
+      <p:sp>
+        <p:nvSpPr>
+          <p:cNvPr id="2" name="Slide Image Placeholder 1"/>
+          <p:cNvSpPr>
+            <a:spLocks noGrp="1" noRot="1" noChangeAspect="1"/>
+          </p:cNvSpPr>
+          <p:nvPr>
+            <p:ph type="sldImg"/>
+          </p:nvPr>
+        </p:nvSpPr>
+        <p:spPr/>
+      </p:sp>
+      <p:sp>
+        <p:nvSpPr>
+          <p:cNvPr id="3" name="Notes Placeholder 2"/>
+          <p:cNvSpPr>
+            <a:spLocks noGrp="1"/>
+          </p:cNvSpPr>
+          <p:nvPr>
+            <p:ph type="body" idx="1"/>
+          </p:nvPr>
+        </p:nvSpPr>
+        <p:spPr/>
+        <p:txBody>
+          <a:bodyPr/>
+          <a:lstStyle/>
+          <a:p>
+            <a:r>
+              <a:rPr lang="en-US" dirty="0"/>
+              <a:t>Yes/No Response Task</a:t>
+            </a:r>
+            <a:endParaRPr lang="en-DK" dirty="0"/>
+          </a:p>
+        </p:txBody>
+      </p:sp>
+      <p:sp>
+        <p:nvSpPr>
+          <p:cNvPr id="4" name="Slide Number Placeholder 3"/>
+          <p:cNvSpPr>
+            <a:spLocks noGrp="1"/>
+          </p:cNvSpPr>
+          <p:nvPr>
+            <p:ph type="sldNum" sz="quarter" idx="5"/>
+          </p:nvPr>
+        </p:nvSpPr>
+        <p:spPr/>
+        <p:txBody>
+          <a:bodyPr/>
+          <a:lstStyle/>
+          <a:p>
+            <a:fld id="{A20644BD-399A-490A-99CC-829CA96D1157}" type="slidenum">
+              <a:rPr lang="en-DK" smtClean="0"/>
+              <a:t>2</a:t>
+            </a:fld>
+            <a:endParaRPr lang="en-DK"/>
+          </a:p>
+        </p:txBody>
+      </p:sp>
+    </p:spTree>
+    <p:extLst>
+      <p:ext uri="{BB962C8B-B14F-4D97-AF65-F5344CB8AC3E}">
+        <p14:creationId xmlns:p14="http://schemas.microsoft.com/office/powerpoint/2010/main" val="1001973503"/>
+      </p:ext>
+    </p:extLst>
+  </p:cSld>
+  <p:clrMapOvr>
+    <a:masterClrMapping/>
+  </p:clrMapOvr>
+</p:notes>
+</file>
+
+<file path=ppt/notesSlides/notesSlide3.xml><?xml version="1.0" encoding="utf-8"?>
+<p:notes xmlns:a="http://schemas.openxmlformats.org/drawingml/2006/main" xmlns:r="http://schemas.openxmlformats.org/officeDocument/2006/relationships" xmlns:p="http://schemas.openxmlformats.org/presentationml/2006/main">
+  <p:cSld>
+    <p:spTree>
+      <p:nvGrpSpPr>
+        <p:cNvPr id="1" name=""/>
+        <p:cNvGrpSpPr/>
+        <p:nvPr/>
+      </p:nvGrpSpPr>
+      <p:grpSpPr>
+        <a:xfrm>
+          <a:off x="0" y="0"/>
+          <a:ext cx="0" cy="0"/>
+          <a:chOff x="0" y="0"/>
+          <a:chExt cx="0" cy="0"/>
+        </a:xfrm>
+      </p:grpSpPr>
+      <p:sp>
+        <p:nvSpPr>
+          <p:cNvPr id="2" name="Slide Image Placeholder 1"/>
+          <p:cNvSpPr>
+            <a:spLocks noGrp="1" noRot="1" noChangeAspect="1"/>
+          </p:cNvSpPr>
+          <p:nvPr>
+            <p:ph type="sldImg"/>
+          </p:nvPr>
+        </p:nvSpPr>
+        <p:spPr/>
+      </p:sp>
+      <p:sp>
+        <p:nvSpPr>
+          <p:cNvPr id="3" name="Notes Placeholder 2"/>
+          <p:cNvSpPr>
+            <a:spLocks noGrp="1"/>
+          </p:cNvSpPr>
+          <p:nvPr>
+            <p:ph type="body" idx="1"/>
+          </p:nvPr>
+        </p:nvSpPr>
+        <p:spPr/>
+        <p:txBody>
+          <a:bodyPr/>
+          <a:lstStyle/>
+          <a:p>
+            <a:r>
+              <a:rPr lang="en-US" dirty="0"/>
+              <a:t>One Interval Forced Choice</a:t>
+            </a:r>
+            <a:endParaRPr lang="en-DK" dirty="0"/>
+          </a:p>
+        </p:txBody>
+      </p:sp>
+      <p:sp>
+        <p:nvSpPr>
+          <p:cNvPr id="4" name="Slide Number Placeholder 3"/>
+          <p:cNvSpPr>
+            <a:spLocks noGrp="1"/>
+          </p:cNvSpPr>
+          <p:nvPr>
+            <p:ph type="sldNum" sz="quarter" idx="5"/>
+          </p:nvPr>
+        </p:nvSpPr>
+        <p:spPr/>
+        <p:txBody>
+          <a:bodyPr/>
+          <a:lstStyle/>
+          <a:p>
+            <a:fld id="{A20644BD-399A-490A-99CC-829CA96D1157}" type="slidenum">
+              <a:rPr lang="en-DK" smtClean="0"/>
+              <a:t>3</a:t>
+            </a:fld>
+            <a:endParaRPr lang="en-DK"/>
+          </a:p>
+        </p:txBody>
+      </p:sp>
+    </p:spTree>
+    <p:extLst>
+      <p:ext uri="{BB962C8B-B14F-4D97-AF65-F5344CB8AC3E}">
+        <p14:creationId xmlns:p14="http://schemas.microsoft.com/office/powerpoint/2010/main" val="3405525621"/>
+      </p:ext>
+    </p:extLst>
+  </p:cSld>
+  <p:clrMapOvr>
+    <a:masterClrMapping/>
+  </p:clrMapOvr>
+</p:notes>
+</file>
+
+<file path=ppt/notesSlides/notesSlide4.xml><?xml version="1.0" encoding="utf-8"?>
+<p:notes xmlns:a="http://schemas.openxmlformats.org/drawingml/2006/main" xmlns:r="http://schemas.openxmlformats.org/officeDocument/2006/relationships" xmlns:p="http://schemas.openxmlformats.org/presentationml/2006/main">
+  <p:cSld>
+    <p:spTree>
+      <p:nvGrpSpPr>
+        <p:cNvPr id="1" name=""/>
+        <p:cNvGrpSpPr/>
+        <p:nvPr/>
+      </p:nvGrpSpPr>
+      <p:grpSpPr>
+        <a:xfrm>
+          <a:off x="0" y="0"/>
+          <a:ext cx="0" cy="0"/>
+          <a:chOff x="0" y="0"/>
+          <a:chExt cx="0" cy="0"/>
+        </a:xfrm>
+      </p:grpSpPr>
+      <p:sp>
+        <p:nvSpPr>
+          <p:cNvPr id="2" name="Slide Image Placeholder 1"/>
+          <p:cNvSpPr>
+            <a:spLocks noGrp="1" noRot="1" noChangeAspect="1"/>
+          </p:cNvSpPr>
+          <p:nvPr>
+            <p:ph type="sldImg"/>
+          </p:nvPr>
+        </p:nvSpPr>
+        <p:spPr/>
+      </p:sp>
+      <p:sp>
+        <p:nvSpPr>
+          <p:cNvPr id="3" name="Notes Placeholder 2"/>
+          <p:cNvSpPr>
+            <a:spLocks noGrp="1"/>
+          </p:cNvSpPr>
+          <p:nvPr>
+            <p:ph type="body" idx="1"/>
+          </p:nvPr>
+        </p:nvSpPr>
+        <p:spPr/>
+        <p:txBody>
+          <a:bodyPr/>
+          <a:lstStyle/>
+          <a:p>
+            <a:r>
+              <a:rPr lang="en-US" dirty="0"/>
+              <a:t>Two Interval Forced Choice Response Task</a:t>
+            </a:r>
+            <a:endParaRPr lang="en-DK" dirty="0"/>
+          </a:p>
+        </p:txBody>
+      </p:sp>
+      <p:sp>
+        <p:nvSpPr>
+          <p:cNvPr id="4" name="Slide Number Placeholder 3"/>
+          <p:cNvSpPr>
+            <a:spLocks noGrp="1"/>
+          </p:cNvSpPr>
+          <p:nvPr>
+            <p:ph type="sldNum" sz="quarter" idx="5"/>
+          </p:nvPr>
+        </p:nvSpPr>
+        <p:spPr/>
+        <p:txBody>
+          <a:bodyPr/>
+          <a:lstStyle/>
+          <a:p>
+            <a:fld id="{A20644BD-399A-490A-99CC-829CA96D1157}" type="slidenum">
+              <a:rPr lang="en-DK" smtClean="0"/>
+              <a:t>4</a:t>
+            </a:fld>
+            <a:endParaRPr lang="en-DK"/>
+          </a:p>
+        </p:txBody>
+      </p:sp>
+    </p:spTree>
+    <p:extLst>
+      <p:ext uri="{BB962C8B-B14F-4D97-AF65-F5344CB8AC3E}">
+        <p14:creationId xmlns:p14="http://schemas.microsoft.com/office/powerpoint/2010/main" val="2385104286"/>
+      </p:ext>
+    </p:extLst>
+  </p:cSld>
+  <p:clrMapOvr>
+    <a:masterClrMapping/>
+  </p:clrMapOvr>
+</p:notes>
+</file>
+
 <file path=ppt/slideLayouts/slideLayout1.xml><?xml version="1.0" encoding="utf-8"?>
 <p:sldLayout xmlns:a="http://schemas.openxmlformats.org/drawingml/2006/main" xmlns:r="http://schemas.openxmlformats.org/officeDocument/2006/relationships" xmlns:p="http://schemas.openxmlformats.org/presentationml/2006/main" type="title" preserve="1">
   <p:cSld name="Title Slide">
@@ -889,7 +1156,7 @@
           <a:p>
             <a:fld id="{F1465E3F-0B9F-47C9-9E08-5C827E095B3E}" type="datetimeFigureOut">
               <a:rPr lang="en-DK" smtClean="0"/>
-              <a:t>27/04/2026</a:t>
+              <a:t>28/04/2026</a:t>
             </a:fld>
             <a:endParaRPr lang="en-DK"/>
           </a:p>
@@ -1059,7 +1326,7 @@
           <a:p>
             <a:fld id="{F1465E3F-0B9F-47C9-9E08-5C827E095B3E}" type="datetimeFigureOut">
               <a:rPr lang="en-DK" smtClean="0"/>
-              <a:t>27/04/2026</a:t>
+              <a:t>28/04/2026</a:t>
             </a:fld>
             <a:endParaRPr lang="en-DK"/>
           </a:p>
@@ -1239,7 +1506,7 @@
           <a:p>
             <a:fld id="{F1465E3F-0B9F-47C9-9E08-5C827E095B3E}" type="datetimeFigureOut">
               <a:rPr lang="en-DK" smtClean="0"/>
-              <a:t>27/04/2026</a:t>
+              <a:t>28/04/2026</a:t>
             </a:fld>
             <a:endParaRPr lang="en-DK"/>
           </a:p>
@@ -1409,7 +1676,7 @@
           <a:p>
             <a:fld id="{F1465E3F-0B9F-47C9-9E08-5C827E095B3E}" type="datetimeFigureOut">
               <a:rPr lang="en-DK" smtClean="0"/>
-              <a:t>27/04/2026</a:t>
+              <a:t>28/04/2026</a:t>
             </a:fld>
             <a:endParaRPr lang="en-DK"/>
           </a:p>
@@ -1655,7 +1922,7 @@
           <a:p>
             <a:fld id="{F1465E3F-0B9F-47C9-9E08-5C827E095B3E}" type="datetimeFigureOut">
               <a:rPr lang="en-DK" smtClean="0"/>
-              <a:t>27/04/2026</a:t>
+              <a:t>28/04/2026</a:t>
             </a:fld>
             <a:endParaRPr lang="en-DK"/>
           </a:p>
@@ -1887,7 +2154,7 @@
           <a:p>
             <a:fld id="{F1465E3F-0B9F-47C9-9E08-5C827E095B3E}" type="datetimeFigureOut">
               <a:rPr lang="en-DK" smtClean="0"/>
-              <a:t>27/04/2026</a:t>
+              <a:t>28/04/2026</a:t>
             </a:fld>
             <a:endParaRPr lang="en-DK"/>
           </a:p>
@@ -2254,7 +2521,7 @@
           <a:p>
             <a:fld id="{F1465E3F-0B9F-47C9-9E08-5C827E095B3E}" type="datetimeFigureOut">
               <a:rPr lang="en-DK" smtClean="0"/>
-              <a:t>27/04/2026</a:t>
+              <a:t>28/04/2026</a:t>
             </a:fld>
             <a:endParaRPr lang="en-DK"/>
           </a:p>
@@ -2372,7 +2639,7 @@
           <a:p>
             <a:fld id="{F1465E3F-0B9F-47C9-9E08-5C827E095B3E}" type="datetimeFigureOut">
               <a:rPr lang="en-DK" smtClean="0"/>
-              <a:t>27/04/2026</a:t>
+              <a:t>28/04/2026</a:t>
             </a:fld>
             <a:endParaRPr lang="en-DK"/>
           </a:p>
@@ -2467,7 +2734,7 @@
           <a:p>
             <a:fld id="{F1465E3F-0B9F-47C9-9E08-5C827E095B3E}" type="datetimeFigureOut">
               <a:rPr lang="en-DK" smtClean="0"/>
-              <a:t>27/04/2026</a:t>
+              <a:t>28/04/2026</a:t>
             </a:fld>
             <a:endParaRPr lang="en-DK"/>
           </a:p>
@@ -2744,7 +3011,7 @@
           <a:p>
             <a:fld id="{F1465E3F-0B9F-47C9-9E08-5C827E095B3E}" type="datetimeFigureOut">
               <a:rPr lang="en-DK" smtClean="0"/>
-              <a:t>27/04/2026</a:t>
+              <a:t>28/04/2026</a:t>
             </a:fld>
             <a:endParaRPr lang="en-DK"/>
           </a:p>
@@ -3001,7 +3268,7 @@
           <a:p>
             <a:fld id="{F1465E3F-0B9F-47C9-9E08-5C827E095B3E}" type="datetimeFigureOut">
               <a:rPr lang="en-DK" smtClean="0"/>
-              <a:t>27/04/2026</a:t>
+              <a:t>28/04/2026</a:t>
             </a:fld>
             <a:endParaRPr lang="en-DK"/>
           </a:p>
@@ -3214,7 +3481,7 @@
           <a:p>
             <a:fld id="{F1465E3F-0B9F-47C9-9E08-5C827E095B3E}" type="datetimeFigureOut">
               <a:rPr lang="en-DK" smtClean="0"/>
-              <a:t>27/04/2026</a:t>
+              <a:t>28/04/2026</a:t>
             </a:fld>
             <a:endParaRPr lang="en-DK"/>
           </a:p>
@@ -3621,10 +3888,10 @@
       </p:grpSpPr>
       <p:pic>
         <p:nvPicPr>
-          <p:cNvPr id="8" name="Picture 7" descr="PTT Label (38,0s),&#10;&#10;AI-generated content may be incorrect.">
+          <p:cNvPr id="7" name="Picture 6" descr="The image is an interactive quiz question asking the user to choose between two intervals (A or B) to indicate when they felt two points.&#10;&#10;AI-generated content may be incorrect.">
             <a:extLst>
               <a:ext uri="{FF2B5EF4-FFF2-40B4-BE49-F238E27FC236}">
-                <a16:creationId xmlns:a16="http://schemas.microsoft.com/office/drawing/2014/main" id="{67110660-29DA-5653-A378-AED011B6B7B1}"/>
+                <a16:creationId xmlns:a16="http://schemas.microsoft.com/office/drawing/2014/main" id="{2982EE1D-7726-9A22-F516-6B99E8B1C9C6}"/>
               </a:ext>
             </a:extLst>
           </p:cNvPr>
@@ -3641,8 +3908,8 @@
         </p:blipFill>
         <p:spPr>
           <a:xfrm>
-            <a:off x="7547315" y="4704208"/>
-            <a:ext cx="6506483" cy="4991797"/>
+            <a:off x="5753171" y="4766586"/>
+            <a:ext cx="6211167" cy="4534533"/>
           </a:xfrm>
           <a:prstGeom prst="rect">
             <a:avLst/>
@@ -3663,8 +3930,8 @@
         </p:nvSpPr>
         <p:spPr>
           <a:xfrm>
-            <a:off x="7547315" y="5216235"/>
-            <a:ext cx="6506483" cy="4570475"/>
+            <a:off x="5753171" y="4878878"/>
+            <a:ext cx="6211167" cy="312420"/>
           </a:xfrm>
           <a:prstGeom prst="rect">
             <a:avLst/>
@@ -3701,12 +3968,104 @@
           </a:p>
         </p:txBody>
       </p:sp>
-      <p:sp>
-        <p:nvSpPr>
-          <p:cNvPr id="3" name="Rectangle 2">
+      <p:cxnSp>
+        <p:nvCxnSpPr>
+          <p:cNvPr id="6" name="Straight Arrow Connector 5">
             <a:extLst>
               <a:ext uri="{FF2B5EF4-FFF2-40B4-BE49-F238E27FC236}">
-                <a16:creationId xmlns:a16="http://schemas.microsoft.com/office/drawing/2014/main" id="{D4A6A19D-7A6D-5907-77C9-117C1F27A18B}"/>
+                <a16:creationId xmlns:a16="http://schemas.microsoft.com/office/drawing/2014/main" id="{66BBA023-8D58-7080-351C-1C2F4AF10521}"/>
+              </a:ext>
+            </a:extLst>
+          </p:cNvPr>
+          <p:cNvCxnSpPr>
+            <a:cxnSpLocks/>
+            <a:stCxn id="23" idx="1"/>
+            <a:endCxn id="11" idx="3"/>
+          </p:cNvCxnSpPr>
+          <p:nvPr/>
+        </p:nvCxnSpPr>
+        <p:spPr>
+          <a:xfrm flipH="1">
+            <a:off x="11964337" y="5373574"/>
+            <a:ext cx="510919" cy="4414"/>
+          </a:xfrm>
+          <a:prstGeom prst="straightConnector1">
+            <a:avLst/>
+          </a:prstGeom>
+          <a:ln w="38100">
+            <a:solidFill>
+              <a:srgbClr val="FF0000"/>
+            </a:solidFill>
+            <a:tailEnd type="triangle"/>
+          </a:ln>
+        </p:spPr>
+        <p:style>
+          <a:lnRef idx="2">
+            <a:schemeClr val="accent1"/>
+          </a:lnRef>
+          <a:fillRef idx="0">
+            <a:schemeClr val="accent1"/>
+          </a:fillRef>
+          <a:effectRef idx="1">
+            <a:schemeClr val="accent1"/>
+          </a:effectRef>
+          <a:fontRef idx="minor">
+            <a:schemeClr val="tx1"/>
+          </a:fontRef>
+        </p:style>
+      </p:cxnSp>
+      <p:cxnSp>
+        <p:nvCxnSpPr>
+          <p:cNvPr id="22" name="Straight Arrow Connector 21">
+            <a:extLst>
+              <a:ext uri="{FF2B5EF4-FFF2-40B4-BE49-F238E27FC236}">
+                <a16:creationId xmlns:a16="http://schemas.microsoft.com/office/drawing/2014/main" id="{CA3F6CB0-E8F1-F0EC-C6EA-81A05CFA9E97}"/>
+              </a:ext>
+            </a:extLst>
+          </p:cNvPr>
+          <p:cNvCxnSpPr>
+            <a:cxnSpLocks/>
+            <a:stCxn id="16" idx="1"/>
+            <a:endCxn id="13" idx="3"/>
+          </p:cNvCxnSpPr>
+          <p:nvPr/>
+        </p:nvCxnSpPr>
+        <p:spPr>
+          <a:xfrm flipH="1">
+            <a:off x="11903982" y="7004857"/>
+            <a:ext cx="571274" cy="0"/>
+          </a:xfrm>
+          <a:prstGeom prst="straightConnector1">
+            <a:avLst/>
+          </a:prstGeom>
+          <a:ln w="38100">
+            <a:solidFill>
+              <a:srgbClr val="FF0000"/>
+            </a:solidFill>
+            <a:tailEnd type="triangle"/>
+          </a:ln>
+        </p:spPr>
+        <p:style>
+          <a:lnRef idx="2">
+            <a:schemeClr val="accent1"/>
+          </a:lnRef>
+          <a:fillRef idx="0">
+            <a:schemeClr val="accent1"/>
+          </a:fillRef>
+          <a:effectRef idx="1">
+            <a:schemeClr val="accent1"/>
+          </a:effectRef>
+          <a:fontRef idx="minor">
+            <a:schemeClr val="tx1"/>
+          </a:fontRef>
+        </p:style>
+      </p:cxnSp>
+      <p:sp>
+        <p:nvSpPr>
+          <p:cNvPr id="11" name="Rectangle 10">
+            <a:extLst>
+              <a:ext uri="{FF2B5EF4-FFF2-40B4-BE49-F238E27FC236}">
+                <a16:creationId xmlns:a16="http://schemas.microsoft.com/office/drawing/2014/main" id="{4E3F4FDD-35A3-A5EE-3C3A-87D8163553BC}"/>
               </a:ext>
             </a:extLst>
           </p:cNvPr>
@@ -3714,9 +4073,9 @@
           <p:nvPr/>
         </p:nvSpPr>
         <p:spPr>
-          <a:xfrm flipV="1">
-            <a:off x="7547315" y="4704209"/>
-            <a:ext cx="6506483" cy="512026"/>
+          <a:xfrm>
+            <a:off x="5753170" y="5191298"/>
+            <a:ext cx="6211167" cy="373380"/>
           </a:xfrm>
           <a:prstGeom prst="rect">
             <a:avLst/>
@@ -3755,174 +4114,10 @@
       </p:sp>
       <p:sp>
         <p:nvSpPr>
-          <p:cNvPr id="4" name="TextBox 3">
+          <p:cNvPr id="13" name="Rectangle 12">
             <a:extLst>
               <a:ext uri="{FF2B5EF4-FFF2-40B4-BE49-F238E27FC236}">
-                <a16:creationId xmlns:a16="http://schemas.microsoft.com/office/drawing/2014/main" id="{B6992C86-570A-07B2-D599-5332A80B853F}"/>
-              </a:ext>
-            </a:extLst>
-          </p:cNvPr>
-          <p:cNvSpPr txBox="1"/>
-          <p:nvPr/>
-        </p:nvSpPr>
-        <p:spPr>
-          <a:xfrm>
-            <a:off x="14686601" y="7209198"/>
-            <a:ext cx="2704202" cy="584775"/>
-          </a:xfrm>
-          <a:prstGeom prst="rect">
-            <a:avLst/>
-          </a:prstGeom>
-          <a:noFill/>
-        </p:spPr>
-        <p:txBody>
-          <a:bodyPr wrap="none" rtlCol="0">
-            <a:spAutoFit/>
-          </a:bodyPr>
-          <a:lstStyle/>
-          <a:p>
-            <a:r>
-              <a:rPr lang="en-US" sz="3200" dirty="0"/>
-              <a:t>Timing display</a:t>
-            </a:r>
-            <a:endParaRPr lang="en-DK" sz="3200" dirty="0"/>
-          </a:p>
-        </p:txBody>
-      </p:sp>
-      <p:cxnSp>
-        <p:nvCxnSpPr>
-          <p:cNvPr id="6" name="Straight Arrow Connector 5">
-            <a:extLst>
-              <a:ext uri="{FF2B5EF4-FFF2-40B4-BE49-F238E27FC236}">
-                <a16:creationId xmlns:a16="http://schemas.microsoft.com/office/drawing/2014/main" id="{66BBA023-8D58-7080-351C-1C2F4AF10521}"/>
-              </a:ext>
-            </a:extLst>
-          </p:cNvPr>
-          <p:cNvCxnSpPr>
-            <a:cxnSpLocks/>
-            <a:stCxn id="4" idx="1"/>
-            <a:endCxn id="2" idx="3"/>
-          </p:cNvCxnSpPr>
-          <p:nvPr/>
-        </p:nvCxnSpPr>
-        <p:spPr>
-          <a:xfrm flipH="1" flipV="1">
-            <a:off x="14053798" y="7501473"/>
-            <a:ext cx="632803" cy="113"/>
-          </a:xfrm>
-          <a:prstGeom prst="straightConnector1">
-            <a:avLst/>
-          </a:prstGeom>
-          <a:ln w="38100">
-            <a:solidFill>
-              <a:srgbClr val="FF0000"/>
-            </a:solidFill>
-            <a:tailEnd type="triangle"/>
-          </a:ln>
-        </p:spPr>
-        <p:style>
-          <a:lnRef idx="2">
-            <a:schemeClr val="accent1"/>
-          </a:lnRef>
-          <a:fillRef idx="0">
-            <a:schemeClr val="accent1"/>
-          </a:fillRef>
-          <a:effectRef idx="1">
-            <a:schemeClr val="accent1"/>
-          </a:effectRef>
-          <a:fontRef idx="minor">
-            <a:schemeClr val="tx1"/>
-          </a:fontRef>
-        </p:style>
-      </p:cxnSp>
-      <p:sp>
-        <p:nvSpPr>
-          <p:cNvPr id="9" name="TextBox 8">
-            <a:extLst>
-              <a:ext uri="{FF2B5EF4-FFF2-40B4-BE49-F238E27FC236}">
-                <a16:creationId xmlns:a16="http://schemas.microsoft.com/office/drawing/2014/main" id="{A7026118-FA07-4E73-8C78-91EA87A038AB}"/>
-              </a:ext>
-            </a:extLst>
-          </p:cNvPr>
-          <p:cNvSpPr txBox="1"/>
-          <p:nvPr/>
-        </p:nvSpPr>
-        <p:spPr>
-          <a:xfrm>
-            <a:off x="14686601" y="4667834"/>
-            <a:ext cx="3769558" cy="584775"/>
-          </a:xfrm>
-          <a:prstGeom prst="rect">
-            <a:avLst/>
-          </a:prstGeom>
-          <a:noFill/>
-        </p:spPr>
-        <p:txBody>
-          <a:bodyPr wrap="none" rtlCol="0">
-            <a:spAutoFit/>
-          </a:bodyPr>
-          <a:lstStyle/>
-          <a:p>
-            <a:r>
-              <a:rPr lang="en-US" sz="3200" dirty="0"/>
-              <a:t>Operator instruction</a:t>
-            </a:r>
-            <a:endParaRPr lang="en-DK" sz="3200" dirty="0"/>
-          </a:p>
-        </p:txBody>
-      </p:sp>
-      <p:cxnSp>
-        <p:nvCxnSpPr>
-          <p:cNvPr id="10" name="Straight Arrow Connector 9">
-            <a:extLst>
-              <a:ext uri="{FF2B5EF4-FFF2-40B4-BE49-F238E27FC236}">
-                <a16:creationId xmlns:a16="http://schemas.microsoft.com/office/drawing/2014/main" id="{F430E7C4-83C8-884D-735D-BEE028885075}"/>
-              </a:ext>
-            </a:extLst>
-          </p:cNvPr>
-          <p:cNvCxnSpPr>
-            <a:cxnSpLocks/>
-            <a:stCxn id="9" idx="1"/>
-            <a:endCxn id="3" idx="3"/>
-          </p:cNvCxnSpPr>
-          <p:nvPr/>
-        </p:nvCxnSpPr>
-        <p:spPr>
-          <a:xfrm flipH="1">
-            <a:off x="14053798" y="4960222"/>
-            <a:ext cx="632803" cy="0"/>
-          </a:xfrm>
-          <a:prstGeom prst="straightConnector1">
-            <a:avLst/>
-          </a:prstGeom>
-          <a:ln w="38100">
-            <a:solidFill>
-              <a:srgbClr val="FF0000"/>
-            </a:solidFill>
-            <a:tailEnd type="triangle"/>
-          </a:ln>
-        </p:spPr>
-        <p:style>
-          <a:lnRef idx="2">
-            <a:schemeClr val="accent1"/>
-          </a:lnRef>
-          <a:fillRef idx="0">
-            <a:schemeClr val="accent1"/>
-          </a:fillRef>
-          <a:effectRef idx="1">
-            <a:schemeClr val="accent1"/>
-          </a:effectRef>
-          <a:fontRef idx="minor">
-            <a:schemeClr val="tx1"/>
-          </a:fontRef>
-        </p:style>
-      </p:cxnSp>
-      <p:sp>
-        <p:nvSpPr>
-          <p:cNvPr id="20" name="Rectangle 19">
-            <a:extLst>
-              <a:ext uri="{FF2B5EF4-FFF2-40B4-BE49-F238E27FC236}">
-                <a16:creationId xmlns:a16="http://schemas.microsoft.com/office/drawing/2014/main" id="{6C839B36-89E5-060B-FD8C-FAAF208A7841}"/>
+                <a16:creationId xmlns:a16="http://schemas.microsoft.com/office/drawing/2014/main" id="{DC2B6747-61C4-3757-9079-24B5D80601B4}"/>
               </a:ext>
             </a:extLst>
           </p:cNvPr>
@@ -3931,8 +4126,8 @@
         </p:nvSpPr>
         <p:spPr>
           <a:xfrm flipV="1">
-            <a:off x="12302836" y="9183977"/>
-            <a:ext cx="1750962" cy="548401"/>
+            <a:off x="5816137" y="5877097"/>
+            <a:ext cx="6087845" cy="2255520"/>
           </a:xfrm>
           <a:prstGeom prst="rect">
             <a:avLst/>
@@ -3971,10 +4166,114 @@
       </p:sp>
       <p:sp>
         <p:nvSpPr>
-          <p:cNvPr id="21" name="TextBox 20">
+          <p:cNvPr id="14" name="Rectangle 13">
             <a:extLst>
               <a:ext uri="{FF2B5EF4-FFF2-40B4-BE49-F238E27FC236}">
-                <a16:creationId xmlns:a16="http://schemas.microsoft.com/office/drawing/2014/main" id="{22087A5E-E5CE-B701-3D38-AA946B9D2C48}"/>
+                <a16:creationId xmlns:a16="http://schemas.microsoft.com/office/drawing/2014/main" id="{C239ACD9-BF0A-4142-4916-870E64CBB241}"/>
+              </a:ext>
+            </a:extLst>
+          </p:cNvPr>
+          <p:cNvSpPr/>
+          <p:nvPr/>
+        </p:nvSpPr>
+        <p:spPr>
+          <a:xfrm>
+            <a:off x="5816137" y="8344121"/>
+            <a:ext cx="6087845" cy="452070"/>
+          </a:xfrm>
+          <a:prstGeom prst="rect">
+            <a:avLst/>
+          </a:prstGeom>
+          <a:noFill/>
+          <a:ln>
+            <a:solidFill>
+              <a:srgbClr val="FF0000"/>
+            </a:solidFill>
+          </a:ln>
+        </p:spPr>
+        <p:style>
+          <a:lnRef idx="2">
+            <a:schemeClr val="accent1">
+              <a:shade val="15000"/>
+            </a:schemeClr>
+          </a:lnRef>
+          <a:fillRef idx="1">
+            <a:schemeClr val="accent1"/>
+          </a:fillRef>
+          <a:effectRef idx="0">
+            <a:schemeClr val="accent1"/>
+          </a:effectRef>
+          <a:fontRef idx="minor">
+            <a:schemeClr val="lt1"/>
+          </a:fontRef>
+        </p:style>
+        <p:txBody>
+          <a:bodyPr rtlCol="0" anchor="ctr"/>
+          <a:lstStyle/>
+          <a:p>
+            <a:pPr algn="ctr"/>
+            <a:endParaRPr lang="en-DK"/>
+          </a:p>
+        </p:txBody>
+      </p:sp>
+      <p:sp>
+        <p:nvSpPr>
+          <p:cNvPr id="15" name="Rectangle 14">
+            <a:extLst>
+              <a:ext uri="{FF2B5EF4-FFF2-40B4-BE49-F238E27FC236}">
+                <a16:creationId xmlns:a16="http://schemas.microsoft.com/office/drawing/2014/main" id="{6D49719F-DAB6-39A3-57CF-BCF751C99F68}"/>
+              </a:ext>
+            </a:extLst>
+          </p:cNvPr>
+          <p:cNvSpPr/>
+          <p:nvPr/>
+        </p:nvSpPr>
+        <p:spPr>
+          <a:xfrm>
+            <a:off x="5816137" y="8792141"/>
+            <a:ext cx="6087845" cy="505561"/>
+          </a:xfrm>
+          <a:prstGeom prst="rect">
+            <a:avLst/>
+          </a:prstGeom>
+          <a:noFill/>
+          <a:ln>
+            <a:solidFill>
+              <a:srgbClr val="FF0000"/>
+            </a:solidFill>
+          </a:ln>
+        </p:spPr>
+        <p:style>
+          <a:lnRef idx="2">
+            <a:schemeClr val="accent1">
+              <a:shade val="15000"/>
+            </a:schemeClr>
+          </a:lnRef>
+          <a:fillRef idx="1">
+            <a:schemeClr val="accent1"/>
+          </a:fillRef>
+          <a:effectRef idx="0">
+            <a:schemeClr val="accent1"/>
+          </a:effectRef>
+          <a:fontRef idx="minor">
+            <a:schemeClr val="lt1"/>
+          </a:fontRef>
+        </p:style>
+        <p:txBody>
+          <a:bodyPr rtlCol="0" anchor="ctr"/>
+          <a:lstStyle/>
+          <a:p>
+            <a:pPr algn="ctr"/>
+            <a:endParaRPr lang="en-DK"/>
+          </a:p>
+        </p:txBody>
+      </p:sp>
+      <p:sp>
+        <p:nvSpPr>
+          <p:cNvPr id="16" name="TextBox 15">
+            <a:extLst>
+              <a:ext uri="{FF2B5EF4-FFF2-40B4-BE49-F238E27FC236}">
+                <a16:creationId xmlns:a16="http://schemas.microsoft.com/office/drawing/2014/main" id="{15732414-D38B-E887-7B0A-70C29A6BD129}"/>
               </a:ext>
             </a:extLst>
           </p:cNvPr>
@@ -3983,8 +4282,8 @@
         </p:nvSpPr>
         <p:spPr>
           <a:xfrm>
-            <a:off x="14686601" y="9165789"/>
-            <a:ext cx="5131837" cy="584775"/>
+            <a:off x="12475256" y="6712469"/>
+            <a:ext cx="1834944" cy="584775"/>
           </a:xfrm>
           <a:prstGeom prst="rect">
             <a:avLst/>
@@ -3999,7 +4298,151 @@
           <a:p>
             <a:r>
               <a:rPr lang="en-US" sz="3200" dirty="0"/>
-              <a:t>Timing information</a:t>
+              <a:t>Options</a:t>
+            </a:r>
+            <a:endParaRPr lang="en-DK" sz="3200" dirty="0"/>
+          </a:p>
+        </p:txBody>
+      </p:sp>
+      <p:sp>
+        <p:nvSpPr>
+          <p:cNvPr id="17" name="TextBox 16">
+            <a:extLst>
+              <a:ext uri="{FF2B5EF4-FFF2-40B4-BE49-F238E27FC236}">
+                <a16:creationId xmlns:a16="http://schemas.microsoft.com/office/drawing/2014/main" id="{DC54EB0D-8BAC-5971-178B-B157AE60BFE3}"/>
+              </a:ext>
+            </a:extLst>
+          </p:cNvPr>
+          <p:cNvSpPr txBox="1"/>
+          <p:nvPr/>
+        </p:nvSpPr>
+        <p:spPr>
+          <a:xfrm>
+            <a:off x="12475256" y="8277769"/>
+            <a:ext cx="4044744" cy="584775"/>
+          </a:xfrm>
+          <a:prstGeom prst="rect">
+            <a:avLst/>
+          </a:prstGeom>
+          <a:noFill/>
+        </p:spPr>
+        <p:txBody>
+          <a:bodyPr wrap="square" rtlCol="0">
+            <a:spAutoFit/>
+          </a:bodyPr>
+          <a:lstStyle/>
+          <a:p>
+            <a:r>
+              <a:rPr lang="en-US" sz="3200" dirty="0"/>
+              <a:t>Response question</a:t>
+            </a:r>
+            <a:endParaRPr lang="en-DK" sz="3200" dirty="0"/>
+          </a:p>
+        </p:txBody>
+      </p:sp>
+      <p:sp>
+        <p:nvSpPr>
+          <p:cNvPr id="18" name="TextBox 17">
+            <a:extLst>
+              <a:ext uri="{FF2B5EF4-FFF2-40B4-BE49-F238E27FC236}">
+                <a16:creationId xmlns:a16="http://schemas.microsoft.com/office/drawing/2014/main" id="{470E0646-7795-0C0A-001A-49E1A90198AC}"/>
+              </a:ext>
+            </a:extLst>
+          </p:cNvPr>
+          <p:cNvSpPr txBox="1"/>
+          <p:nvPr/>
+        </p:nvSpPr>
+        <p:spPr>
+          <a:xfrm>
+            <a:off x="12475256" y="8752534"/>
+            <a:ext cx="4044744" cy="584775"/>
+          </a:xfrm>
+          <a:prstGeom prst="rect">
+            <a:avLst/>
+          </a:prstGeom>
+          <a:noFill/>
+        </p:spPr>
+        <p:txBody>
+          <a:bodyPr wrap="square" rtlCol="0">
+            <a:spAutoFit/>
+          </a:bodyPr>
+          <a:lstStyle/>
+          <a:p>
+            <a:r>
+              <a:rPr lang="en-US" sz="3200" dirty="0"/>
+              <a:t>Answer</a:t>
+            </a:r>
+            <a:endParaRPr lang="en-DK" sz="3200" dirty="0"/>
+          </a:p>
+        </p:txBody>
+      </p:sp>
+      <p:sp>
+        <p:nvSpPr>
+          <p:cNvPr id="19" name="TextBox 18">
+            <a:extLst>
+              <a:ext uri="{FF2B5EF4-FFF2-40B4-BE49-F238E27FC236}">
+                <a16:creationId xmlns:a16="http://schemas.microsoft.com/office/drawing/2014/main" id="{B3B73288-9E9F-C9C1-7EDE-91667642291C}"/>
+              </a:ext>
+            </a:extLst>
+          </p:cNvPr>
+          <p:cNvSpPr txBox="1"/>
+          <p:nvPr/>
+        </p:nvSpPr>
+        <p:spPr>
+          <a:xfrm>
+            <a:off x="12475256" y="4742700"/>
+            <a:ext cx="4044744" cy="584775"/>
+          </a:xfrm>
+          <a:prstGeom prst="rect">
+            <a:avLst/>
+          </a:prstGeom>
+          <a:noFill/>
+        </p:spPr>
+        <p:txBody>
+          <a:bodyPr wrap="square" rtlCol="0">
+            <a:spAutoFit/>
+          </a:bodyPr>
+          <a:lstStyle/>
+          <a:p>
+            <a:r>
+              <a:rPr lang="en-US" sz="3200" dirty="0"/>
+              <a:t>Intensity</a:t>
+            </a:r>
+            <a:endParaRPr lang="en-DK" sz="3200" dirty="0"/>
+          </a:p>
+        </p:txBody>
+      </p:sp>
+      <p:sp>
+        <p:nvSpPr>
+          <p:cNvPr id="23" name="TextBox 22">
+            <a:extLst>
+              <a:ext uri="{FF2B5EF4-FFF2-40B4-BE49-F238E27FC236}">
+                <a16:creationId xmlns:a16="http://schemas.microsoft.com/office/drawing/2014/main" id="{97A00D71-9574-CC18-B7DC-AD46152D395A}"/>
+              </a:ext>
+            </a:extLst>
+          </p:cNvPr>
+          <p:cNvSpPr txBox="1"/>
+          <p:nvPr/>
+        </p:nvSpPr>
+        <p:spPr>
+          <a:xfrm>
+            <a:off x="12475256" y="5081186"/>
+            <a:ext cx="4044744" cy="584775"/>
+          </a:xfrm>
+          <a:prstGeom prst="rect">
+            <a:avLst/>
+          </a:prstGeom>
+          <a:noFill/>
+        </p:spPr>
+        <p:txBody>
+          <a:bodyPr wrap="square" rtlCol="0">
+            <a:spAutoFit/>
+          </a:bodyPr>
+          <a:lstStyle/>
+          <a:p>
+            <a:r>
+              <a:rPr lang="en-US" sz="3200" dirty="0"/>
+              <a:t>Progress</a:t>
             </a:r>
             <a:endParaRPr lang="en-DK" sz="3200" dirty="0"/>
           </a:p>
@@ -4007,24 +4450,70 @@
       </p:sp>
       <p:cxnSp>
         <p:nvCxnSpPr>
-          <p:cNvPr id="22" name="Straight Arrow Connector 21">
+          <p:cNvPr id="28" name="Straight Arrow Connector 27">
             <a:extLst>
               <a:ext uri="{FF2B5EF4-FFF2-40B4-BE49-F238E27FC236}">
-                <a16:creationId xmlns:a16="http://schemas.microsoft.com/office/drawing/2014/main" id="{CA3F6CB0-E8F1-F0EC-C6EA-81A05CFA9E97}"/>
+                <a16:creationId xmlns:a16="http://schemas.microsoft.com/office/drawing/2014/main" id="{15227365-E0EE-618C-5C22-5F0438784ABB}"/>
               </a:ext>
             </a:extLst>
           </p:cNvPr>
           <p:cNvCxnSpPr>
             <a:cxnSpLocks/>
-            <a:stCxn id="21" idx="1"/>
-            <a:endCxn id="20" idx="3"/>
+            <a:stCxn id="18" idx="1"/>
+            <a:endCxn id="15" idx="3"/>
           </p:cNvCxnSpPr>
           <p:nvPr/>
         </p:nvCxnSpPr>
         <p:spPr>
           <a:xfrm flipH="1">
-            <a:off x="14053798" y="9458177"/>
-            <a:ext cx="632803" cy="0"/>
+            <a:off x="11903982" y="9044922"/>
+            <a:ext cx="571274" cy="0"/>
+          </a:xfrm>
+          <a:prstGeom prst="straightConnector1">
+            <a:avLst/>
+          </a:prstGeom>
+          <a:ln w="38100">
+            <a:solidFill>
+              <a:srgbClr val="FF0000"/>
+            </a:solidFill>
+            <a:tailEnd type="triangle"/>
+          </a:ln>
+        </p:spPr>
+        <p:style>
+          <a:lnRef idx="2">
+            <a:schemeClr val="accent1"/>
+          </a:lnRef>
+          <a:fillRef idx="0">
+            <a:schemeClr val="accent1"/>
+          </a:fillRef>
+          <a:effectRef idx="1">
+            <a:schemeClr val="accent1"/>
+          </a:effectRef>
+          <a:fontRef idx="minor">
+            <a:schemeClr val="tx1"/>
+          </a:fontRef>
+        </p:style>
+      </p:cxnSp>
+      <p:cxnSp>
+        <p:nvCxnSpPr>
+          <p:cNvPr id="31" name="Straight Arrow Connector 30">
+            <a:extLst>
+              <a:ext uri="{FF2B5EF4-FFF2-40B4-BE49-F238E27FC236}">
+                <a16:creationId xmlns:a16="http://schemas.microsoft.com/office/drawing/2014/main" id="{EDDF0BA1-ED82-580F-A00B-7B34A45C2A7F}"/>
+              </a:ext>
+            </a:extLst>
+          </p:cNvPr>
+          <p:cNvCxnSpPr>
+            <a:cxnSpLocks/>
+            <a:stCxn id="17" idx="1"/>
+            <a:endCxn id="14" idx="3"/>
+          </p:cNvCxnSpPr>
+          <p:nvPr/>
+        </p:nvCxnSpPr>
+        <p:spPr>
+          <a:xfrm flipH="1" flipV="1">
+            <a:off x="11903982" y="8570156"/>
+            <a:ext cx="571274" cy="1"/>
           </a:xfrm>
           <a:prstGeom prst="straightConnector1">
             <a:avLst/>
@@ -4055,6 +4544,186 @@
     <p:extLst>
       <p:ext uri="{BB962C8B-B14F-4D97-AF65-F5344CB8AC3E}">
         <p14:creationId xmlns:p14="http://schemas.microsoft.com/office/powerpoint/2010/main" val="786876301"/>
+      </p:ext>
+    </p:extLst>
+  </p:cSld>
+  <p:clrMapOvr>
+    <a:masterClrMapping/>
+  </p:clrMapOvr>
+</p:sld>
+</file>
+
+<file path=ppt/slides/slide2.xml><?xml version="1.0" encoding="utf-8"?>
+<p:sld xmlns:a="http://schemas.openxmlformats.org/drawingml/2006/main" xmlns:r="http://schemas.openxmlformats.org/officeDocument/2006/relationships" xmlns:p="http://schemas.openxmlformats.org/presentationml/2006/main">
+  <p:cSld>
+    <p:spTree>
+      <p:nvGrpSpPr>
+        <p:cNvPr id="1" name=""/>
+        <p:cNvGrpSpPr/>
+        <p:nvPr/>
+      </p:nvGrpSpPr>
+      <p:grpSpPr>
+        <a:xfrm>
+          <a:off x="0" y="0"/>
+          <a:ext cx="0" cy="0"/>
+          <a:chOff x="0" y="0"/>
+          <a:chExt cx="0" cy="0"/>
+        </a:xfrm>
+      </p:grpSpPr>
+      <p:pic>
+        <p:nvPicPr>
+          <p:cNvPr id="3" name="Picture 2" descr="Yes.&#10;&#10;AI-generated content may be incorrect.">
+            <a:extLst>
+              <a:ext uri="{FF2B5EF4-FFF2-40B4-BE49-F238E27FC236}">
+                <a16:creationId xmlns:a16="http://schemas.microsoft.com/office/drawing/2014/main" id="{3DB8C383-C983-4640-CB40-12A229D54288}"/>
+              </a:ext>
+            </a:extLst>
+          </p:cNvPr>
+          <p:cNvPicPr>
+            <a:picLocks noChangeAspect="1"/>
+          </p:cNvPicPr>
+          <p:nvPr/>
+        </p:nvPicPr>
+        <p:blipFill>
+          <a:blip r:embed="rId3"/>
+          <a:stretch>
+            <a:fillRect/>
+          </a:stretch>
+        </p:blipFill>
+        <p:spPr>
+          <a:xfrm>
+            <a:off x="7756894" y="5375814"/>
+            <a:ext cx="6087325" cy="3648584"/>
+          </a:xfrm>
+          <a:prstGeom prst="rect">
+            <a:avLst/>
+          </a:prstGeom>
+        </p:spPr>
+      </p:pic>
+    </p:spTree>
+    <p:extLst>
+      <p:ext uri="{BB962C8B-B14F-4D97-AF65-F5344CB8AC3E}">
+        <p14:creationId xmlns:p14="http://schemas.microsoft.com/office/powerpoint/2010/main" val="3194112439"/>
+      </p:ext>
+    </p:extLst>
+  </p:cSld>
+  <p:clrMapOvr>
+    <a:masterClrMapping/>
+  </p:clrMapOvr>
+</p:sld>
+</file>
+
+<file path=ppt/slides/slide3.xml><?xml version="1.0" encoding="utf-8"?>
+<p:sld xmlns:a="http://schemas.openxmlformats.org/drawingml/2006/main" xmlns:r="http://schemas.openxmlformats.org/officeDocument/2006/relationships" xmlns:p="http://schemas.openxmlformats.org/presentationml/2006/main">
+  <p:cSld>
+    <p:spTree>
+      <p:nvGrpSpPr>
+        <p:cNvPr id="1" name=""/>
+        <p:cNvGrpSpPr/>
+        <p:nvPr/>
+      </p:nvGrpSpPr>
+      <p:grpSpPr>
+        <a:xfrm>
+          <a:off x="0" y="0"/>
+          <a:ext cx="0" cy="0"/>
+          <a:chOff x="0" y="0"/>
+          <a:chExt cx="0" cy="0"/>
+        </a:xfrm>
+      </p:grpSpPr>
+      <p:pic>
+        <p:nvPicPr>
+          <p:cNvPr id="3" name="Picture 2" descr="The image shows a visual representation of a diagram asking whether two points are oriented along the same line (Along) or perpendicular to each other (Across).&#10;&#10;AI-generated content may be incorrect.">
+            <a:extLst>
+              <a:ext uri="{FF2B5EF4-FFF2-40B4-BE49-F238E27FC236}">
+                <a16:creationId xmlns:a16="http://schemas.microsoft.com/office/drawing/2014/main" id="{2FA0DAD8-537A-4D97-D159-D34ED64404DD}"/>
+              </a:ext>
+            </a:extLst>
+          </p:cNvPr>
+          <p:cNvPicPr>
+            <a:picLocks noChangeAspect="1"/>
+          </p:cNvPicPr>
+          <p:nvPr/>
+        </p:nvPicPr>
+        <p:blipFill>
+          <a:blip r:embed="rId3"/>
+          <a:stretch>
+            <a:fillRect/>
+          </a:stretch>
+        </p:blipFill>
+        <p:spPr>
+          <a:xfrm>
+            <a:off x="7628289" y="5385340"/>
+            <a:ext cx="6344535" cy="3629532"/>
+          </a:xfrm>
+          <a:prstGeom prst="rect">
+            <a:avLst/>
+          </a:prstGeom>
+        </p:spPr>
+      </p:pic>
+    </p:spTree>
+    <p:extLst>
+      <p:ext uri="{BB962C8B-B14F-4D97-AF65-F5344CB8AC3E}">
+        <p14:creationId xmlns:p14="http://schemas.microsoft.com/office/powerpoint/2010/main" val="1573615222"/>
+      </p:ext>
+    </p:extLst>
+  </p:cSld>
+  <p:clrMapOvr>
+    <a:masterClrMapping/>
+  </p:clrMapOvr>
+</p:sld>
+</file>
+
+<file path=ppt/slides/slide4.xml><?xml version="1.0" encoding="utf-8"?>
+<p:sld xmlns:a="http://schemas.openxmlformats.org/drawingml/2006/main" xmlns:r="http://schemas.openxmlformats.org/officeDocument/2006/relationships" xmlns:p="http://schemas.openxmlformats.org/presentationml/2006/main">
+  <p:cSld>
+    <p:spTree>
+      <p:nvGrpSpPr>
+        <p:cNvPr id="1" name=""/>
+        <p:cNvGrpSpPr/>
+        <p:nvPr/>
+      </p:nvGrpSpPr>
+      <p:grpSpPr>
+        <a:xfrm>
+          <a:off x="0" y="0"/>
+          <a:ext cx="0" cy="0"/>
+          <a:chOff x="0" y="0"/>
+          <a:chExt cx="0" cy="0"/>
+        </a:xfrm>
+      </p:grpSpPr>
+      <p:pic>
+        <p:nvPicPr>
+          <p:cNvPr id="3" name="Picture 2" descr="A diagram depicts a question prompting the user to identify when they felt two points, offering two interval options, A and B.&#10;&#10;AI-generated content may be incorrect.">
+            <a:extLst>
+              <a:ext uri="{FF2B5EF4-FFF2-40B4-BE49-F238E27FC236}">
+                <a16:creationId xmlns:a16="http://schemas.microsoft.com/office/drawing/2014/main" id="{BCAAFD94-D79A-AA1C-ABFB-DBB666547339}"/>
+              </a:ext>
+            </a:extLst>
+          </p:cNvPr>
+          <p:cNvPicPr>
+            <a:picLocks noChangeAspect="1"/>
+          </p:cNvPicPr>
+          <p:nvPr/>
+        </p:nvPicPr>
+        <p:blipFill>
+          <a:blip r:embed="rId3"/>
+          <a:stretch>
+            <a:fillRect/>
+          </a:stretch>
+        </p:blipFill>
+        <p:spPr>
+          <a:xfrm>
+            <a:off x="7714026" y="5661604"/>
+            <a:ext cx="6173061" cy="3077004"/>
+          </a:xfrm>
+          <a:prstGeom prst="rect">
+            <a:avLst/>
+          </a:prstGeom>
+        </p:spPr>
+      </p:pic>
+    </p:spTree>
+    <p:extLst>
+      <p:ext uri="{BB962C8B-B14F-4D97-AF65-F5344CB8AC3E}">
+        <p14:creationId xmlns:p14="http://schemas.microsoft.com/office/powerpoint/2010/main" val="3571802870"/>
       </p:ext>
     </p:extLst>
   </p:cSld>
@@ -4695,6 +5364,26 @@
 </file>
 
 <file path=customXml/item1.xml><?xml version="1.0" encoding="utf-8"?>
+<p:properties xmlns:p="http://schemas.microsoft.com/office/2006/metadata/properties" xmlns:xsi="http://www.w3.org/2001/XMLSchema-instance" xmlns:pc="http://schemas.microsoft.com/office/infopath/2007/PartnerControls">
+  <documentManagement>
+    <TaxCatchAll xmlns="6dfb7b4b-871d-4c24-9d42-16b14ecd044c" xsi:nil="true"/>
+    <lcf76f155ced4ddcb4097134ff3c332f xmlns="51c7d8ad-74c8-4833-8478-0d0a5cafce0c">
+      <Terms xmlns="http://schemas.microsoft.com/office/infopath/2007/PartnerControls"/>
+    </lcf76f155ced4ddcb4097134ff3c332f>
+  </documentManagement>
+</p:properties>
+</file>
+
+<file path=customXml/item2.xml><?xml version="1.0" encoding="utf-8"?>
+<?mso-contentType ?>
+<FormTemplates xmlns="http://schemas.microsoft.com/sharepoint/v3/contenttype/forms">
+  <Display>DocumentLibraryForm</Display>
+  <Edit>DocumentLibraryForm</Edit>
+  <New>DocumentLibraryForm</New>
+</FormTemplates>
+</file>
+
+<file path=customXml/item3.xml><?xml version="1.0" encoding="utf-8"?>
 <ct:contentTypeSchema xmlns:ct="http://schemas.microsoft.com/office/2006/metadata/contentType" xmlns:ma="http://schemas.microsoft.com/office/2006/metadata/properties/metaAttributes" ct:_="" ma:_="" ma:contentTypeName="Document" ma:contentTypeID="0x0101005B996248A2D0E04D87B9DBB54D269DA4" ma:contentTypeVersion="18" ma:contentTypeDescription="Create a new document." ma:contentTypeScope="" ma:versionID="f22bde94a6705f7f7e236c14bc19f189">
   <xsd:schema xmlns:xsd="http://www.w3.org/2001/XMLSchema" xmlns:xs="http://www.w3.org/2001/XMLSchema" xmlns:p="http://schemas.microsoft.com/office/2006/metadata/properties" xmlns:ns2="51c7d8ad-74c8-4833-8478-0d0a5cafce0c" xmlns:ns3="6dfb7b4b-871d-4c24-9d42-16b14ecd044c" targetNamespace="http://schemas.microsoft.com/office/2006/metadata/properties" ma:root="true" ma:fieldsID="273248db29f554cba2c15e8dd349c138" ns2:_="" ns3:_="">
     <xsd:import namespace="51c7d8ad-74c8-4833-8478-0d0a5cafce0c"/>
@@ -4949,27 +5638,32 @@
 </ct:contentTypeSchema>
 </file>
 
-<file path=customXml/item2.xml><?xml version="1.0" encoding="utf-8"?>
-<?mso-contentType ?>
-<FormTemplates xmlns="http://schemas.microsoft.com/sharepoint/v3/contenttype/forms">
-  <Display>DocumentLibraryForm</Display>
-  <Edit>DocumentLibraryForm</Edit>
-  <New>DocumentLibraryForm</New>
-</FormTemplates>
+<file path=customXml/itemProps1.xml><?xml version="1.0" encoding="utf-8"?>
+<ds:datastoreItem xmlns:ds="http://schemas.openxmlformats.org/officeDocument/2006/customXml" ds:itemID="{2EF670CE-B0AA-4D52-AFC6-AA4BF7D46EEA}">
+  <ds:schemaRefs>
+    <ds:schemaRef ds:uri="http://purl.org/dc/elements/1.1/"/>
+    <ds:schemaRef ds:uri="51c7d8ad-74c8-4833-8478-0d0a5cafce0c"/>
+    <ds:schemaRef ds:uri="http://purl.org/dc/terms/"/>
+    <ds:schemaRef ds:uri="6dfb7b4b-871d-4c24-9d42-16b14ecd044c"/>
+    <ds:schemaRef ds:uri="http://schemas.openxmlformats.org/package/2006/metadata/core-properties"/>
+    <ds:schemaRef ds:uri="http://schemas.microsoft.com/office/2006/documentManagement/types"/>
+    <ds:schemaRef ds:uri="http://schemas.microsoft.com/office/infopath/2007/PartnerControls"/>
+    <ds:schemaRef ds:uri="http://schemas.microsoft.com/office/2006/metadata/properties"/>
+    <ds:schemaRef ds:uri="http://www.w3.org/XML/1998/namespace"/>
+    <ds:schemaRef ds:uri="http://purl.org/dc/dcmitype/"/>
+  </ds:schemaRefs>
+</ds:datastoreItem>
 </file>
 
-<file path=customXml/item3.xml><?xml version="1.0" encoding="utf-8"?>
-<p:properties xmlns:p="http://schemas.microsoft.com/office/2006/metadata/properties" xmlns:xsi="http://www.w3.org/2001/XMLSchema-instance" xmlns:pc="http://schemas.microsoft.com/office/infopath/2007/PartnerControls">
-  <documentManagement>
-    <TaxCatchAll xmlns="6dfb7b4b-871d-4c24-9d42-16b14ecd044c" xsi:nil="true"/>
-    <lcf76f155ced4ddcb4097134ff3c332f xmlns="51c7d8ad-74c8-4833-8478-0d0a5cafce0c">
-      <Terms xmlns="http://schemas.microsoft.com/office/infopath/2007/PartnerControls"/>
-    </lcf76f155ced4ddcb4097134ff3c332f>
-  </documentManagement>
-</p:properties>
+<file path=customXml/itemProps2.xml><?xml version="1.0" encoding="utf-8"?>
+<ds:datastoreItem xmlns:ds="http://schemas.openxmlformats.org/officeDocument/2006/customXml" ds:itemID="{EF875D47-8106-485E-98E0-D60C6A98DA6A}">
+  <ds:schemaRefs>
+    <ds:schemaRef ds:uri="http://schemas.microsoft.com/sharepoint/v3/contenttype/forms"/>
+  </ds:schemaRefs>
+</ds:datastoreItem>
 </file>
 
-<file path=customXml/itemProps1.xml><?xml version="1.0" encoding="utf-8"?>
+<file path=customXml/itemProps3.xml><?xml version="1.0" encoding="utf-8"?>
 <ds:datastoreItem xmlns:ds="http://schemas.openxmlformats.org/officeDocument/2006/customXml" ds:itemID="{172A1115-3E72-42E2-A544-7EAA53D3702E}">
   <ds:schemaRefs>
     <ds:schemaRef ds:uri="http://schemas.microsoft.com/office/2006/metadata/contentType"/>
@@ -4986,23 +5680,4 @@
     <ds:schemaRef ds:uri="http://schemas.microsoft.com/internal/obd"/>
   </ds:schemaRefs>
 </ds:datastoreItem>
-</file>
-
-<file path=customXml/itemProps2.xml><?xml version="1.0" encoding="utf-8"?>
-<ds:datastoreItem xmlns:ds="http://schemas.openxmlformats.org/officeDocument/2006/customXml" ds:itemID="{EF875D47-8106-485E-98E0-D60C6A98DA6A}">
-  <ds:schemaRefs>
-    <ds:schemaRef ds:uri="http://schemas.microsoft.com/sharepoint/v3/contenttype/forms"/>
-  </ds:schemaRefs>
-</ds:datastoreItem>
-</file>
-
-<file path=customXml/itemProps3.xml><?xml version="1.0" encoding="utf-8"?>
-<ds:datastoreItem xmlns:ds="http://schemas.openxmlformats.org/officeDocument/2006/customXml" ds:itemID="{2EF670CE-B0AA-4D52-AFC6-AA4BF7D46EEA}">
-  <ds:schemaRefs>
-    <ds:schemaRef ds:uri="http://schemas.microsoft.com/office/2006/metadata/properties"/>
-    <ds:schemaRef ds:uri="http://schemas.microsoft.com/office/infopath/2007/PartnerControls"/>
-    <ds:schemaRef ds:uri="6dfb7b4b-871d-4c24-9d42-16b14ecd044c"/>
-    <ds:schemaRef ds:uri="51c7d8ad-74c8-4833-8478-0d0a5cafce0c"/>
-  </ds:schemaRefs>
-</ds:datastoreItem>
 </file>
</xml_diff>